<commit_message>
Update project presentation content order
Co-authored-by: Copilot <223556219+Copilot@users.noreply.github.com>
</commit_message>
<xml_diff>
--- a/NEON_SNAKE_한국어_한장씩_클릭공개.pptx
+++ b/NEON_SNAKE_한국어_한장씩_클릭공개.pptx
@@ -7351,7 +7351,7 @@
                 </a:solidFill>
                 <a:latin typeface="Microsoft YaHei" panose="020B0503020204020204" pitchFamily="34" charset="-122"/>
               </a:rPr>
-              <a:t>먹이를 먹고 성장</a:t>
+              <a:t>고양이 도우미</a:t>
             </a:r>
             <a:endParaRPr lang="zh-CN" altLang="en-US" b="1">
               <a:solidFill>
@@ -7397,7 +7397,7 @@
                 </a:solidFill>
                 <a:latin typeface="Microsoft YaHei" panose="020B0503020204020204" pitchFamily="34" charset="-122"/>
               </a:rPr>
-              <a:t>🍩  🍕  🧋  🍓  💎  ⭐</a:t>
+              <a:t>🐱  ✨  💬</a:t>
             </a:r>
           </a:p>
         </p:txBody>
@@ -7417,7 +7417,7 @@
         <p:spPr>
           <a:xfrm>
             <a:off x="1016000" y="4394200"/>
-            <a:ext cx="2743200" cy="169277"/>
+            <a:ext cx="2743200" cy="338554"/>
           </a:xfrm>
           <a:prstGeom prst="rect">
             <a:avLst/>
@@ -7437,7 +7437,43 @@
                 </a:solidFill>
                 <a:latin typeface="Microsoft YaHei" panose="020B0503020204020204" pitchFamily="34" charset="-122"/>
               </a:rPr>
-              <a:t>먹이를 먹으면 점수를 얻고 몸이 길어집니다</a:t>
+              <a:t>먹이</a:t>
+            </a:r>
+            <a:r>
+              <a:rPr lang="en-US" altLang="ko-KR" sz="1100">
+                <a:solidFill>
+                  <a:srgbClr val="94A3B8"/>
+                </a:solidFill>
+                <a:latin typeface="Microsoft YaHei" panose="020B0503020204020204" pitchFamily="34" charset="-122"/>
+              </a:rPr>
+              <a:t>·</a:t>
+            </a:r>
+            <a:r>
+              <a:rPr lang="ko-KR" altLang="en-US" sz="1100">
+                <a:solidFill>
+                  <a:srgbClr val="94A3B8"/>
+                </a:solidFill>
+                <a:latin typeface="Microsoft YaHei" panose="020B0503020204020204" pitchFamily="34" charset="-122"/>
+              </a:rPr>
+              <a:t>콤보</a:t>
+            </a:r>
+            <a:r>
+              <a:rPr lang="en-US" altLang="ko-KR" sz="1100">
+                <a:solidFill>
+                  <a:srgbClr val="94A3B8"/>
+                </a:solidFill>
+                <a:latin typeface="Microsoft YaHei" panose="020B0503020204020204" pitchFamily="34" charset="-122"/>
+              </a:rPr>
+              <a:t>·</a:t>
+            </a:r>
+            <a:r>
+              <a:rPr lang="ko-KR" altLang="en-US" sz="1100">
+                <a:solidFill>
+                  <a:srgbClr val="94A3B8"/>
+                </a:solidFill>
+                <a:latin typeface="Microsoft YaHei" panose="020B0503020204020204" pitchFamily="34" charset="-122"/>
+              </a:rPr>
+              <a:t>레벨업 등 주요 순간에 표정과 대사로 반응합니다</a:t>
             </a:r>
             <a:r>
               <a:rPr lang="en-US" altLang="ko-KR" sz="1100">
@@ -7472,7 +7508,7 @@
         <p:spPr>
           <a:xfrm>
             <a:off x="1016000" y="4699000"/>
-            <a:ext cx="2743200" cy="507831"/>
+            <a:ext cx="2743200" cy="338554"/>
           </a:xfrm>
           <a:prstGeom prst="rect">
             <a:avLst/>
@@ -7486,13 +7522,22 @@
           <a:lstStyle/>
           <a:p>
             <a:r>
+              <a:rPr lang="ko-KR" altLang="en-US" sz="1100">
+                <a:solidFill>
+                  <a:srgbClr val="94A3B8"/>
+                </a:solidFill>
+                <a:latin typeface="Microsoft YaHei" panose="020B0503020204020204" pitchFamily="34" charset="-122"/>
+              </a:rPr>
+              <a:t>몬스터를 미리 알려주고</a:t>
+            </a:r>
+            <a:r>
               <a:rPr lang="en-US" altLang="ko-KR" sz="1100">
                 <a:solidFill>
                   <a:srgbClr val="94A3B8"/>
                 </a:solidFill>
                 <a:latin typeface="Microsoft YaHei" panose="020B0503020204020204" pitchFamily="34" charset="-122"/>
               </a:rPr>
-              <a:t>2.6</a:t>
+              <a:t>, </a:t>
             </a:r>
             <a:r>
               <a:rPr lang="ko-KR" altLang="en-US" sz="1100">
@@ -7501,7 +7546,7 @@
                 </a:solidFill>
                 <a:latin typeface="Microsoft YaHei" panose="020B0503020204020204" pitchFamily="34" charset="-122"/>
               </a:rPr>
-              <a:t>초 안에 연속으로 먹으면 콤보가 최대 </a:t>
+              <a:t>언어</a:t>
             </a:r>
             <a:r>
               <a:rPr lang="en-US" altLang="ko-KR" sz="1100">
@@ -7510,7 +7555,7 @@
                 </a:solidFill>
                 <a:latin typeface="Microsoft YaHei" panose="020B0503020204020204" pitchFamily="34" charset="-122"/>
               </a:rPr>
-              <a:t>x5</a:t>
+              <a:t>·</a:t>
             </a:r>
             <a:r>
               <a:rPr lang="ko-KR" altLang="en-US" sz="1100">
@@ -7519,61 +7564,7 @@
                 </a:solidFill>
                 <a:latin typeface="Microsoft YaHei" panose="020B0503020204020204" pitchFamily="34" charset="-122"/>
               </a:rPr>
-              <a:t>까지 증가하고</a:t>
-            </a:r>
-            <a:r>
-              <a:rPr lang="en-US" altLang="ko-KR" sz="1100">
-                <a:solidFill>
-                  <a:srgbClr val="94A3B8"/>
-                </a:solidFill>
-                <a:latin typeface="Microsoft YaHei" panose="020B0503020204020204" pitchFamily="34" charset="-122"/>
-              </a:rPr>
-              <a:t>, </a:t>
-            </a:r>
-            <a:r>
-              <a:rPr lang="ko-KR" altLang="en-US" sz="1100">
-                <a:solidFill>
-                  <a:srgbClr val="94A3B8"/>
-                </a:solidFill>
-                <a:latin typeface="Microsoft YaHei" panose="020B0503020204020204" pitchFamily="34" charset="-122"/>
-              </a:rPr>
-              <a:t>한 번에 최대 </a:t>
-            </a:r>
-            <a:r>
-              <a:rPr lang="en-US" altLang="ko-KR" sz="1100">
-                <a:solidFill>
-                  <a:srgbClr val="94A3B8"/>
-                </a:solidFill>
-                <a:latin typeface="Microsoft YaHei" panose="020B0503020204020204" pitchFamily="34" charset="-122"/>
-              </a:rPr>
-              <a:t>50</a:t>
-            </a:r>
-            <a:r>
-              <a:rPr lang="ko-KR" altLang="en-US" sz="1100">
-                <a:solidFill>
-                  <a:srgbClr val="94A3B8"/>
-                </a:solidFill>
-                <a:latin typeface="Microsoft YaHei" panose="020B0503020204020204" pitchFamily="34" charset="-122"/>
-              </a:rPr>
-              <a:t>점</a:t>
-            </a:r>
-            <a:r>
-              <a:rPr lang="en-US" altLang="ko-KR" sz="1100">
-                <a:solidFill>
-                  <a:srgbClr val="94A3B8"/>
-                </a:solidFill>
-                <a:latin typeface="Microsoft YaHei" panose="020B0503020204020204" pitchFamily="34" charset="-122"/>
-              </a:rPr>
-              <a:t>! </a:t>
-            </a:r>
-            <a:r>
-              <a:rPr lang="ko-KR" altLang="en-US" sz="1100">
-                <a:solidFill>
-                  <a:srgbClr val="94A3B8"/>
-                </a:solidFill>
-                <a:latin typeface="Microsoft YaHei" panose="020B0503020204020204" pitchFamily="34" charset="-122"/>
-              </a:rPr>
-              <a:t>레벨이 오를수록 속도도 빨라집니다</a:t>
+              <a:t>수다 설정을 지원합니다</a:t>
             </a:r>
             <a:r>
               <a:rPr lang="en-US" altLang="ko-KR" sz="1100">
@@ -7674,7 +7665,7 @@
                 </a:solidFill>
                 <a:latin typeface="Microsoft YaHei" panose="020B0503020204020204" pitchFamily="34" charset="-122"/>
               </a:rPr>
-              <a:t>몬스터 피하기</a:t>
+              <a:t>몸에 닿아도 계속 플레이</a:t>
             </a:r>
             <a:endParaRPr lang="zh-CN" altLang="en-US" b="1">
               <a:solidFill>
@@ -7720,25 +7711,7 @@
                 </a:solidFill>
                 <a:latin typeface="Microsoft YaHei" panose="020B0503020204020204" pitchFamily="34" charset="-122"/>
               </a:rPr>
-              <a:t>👾  </a:t>
-            </a:r>
-            <a:r>
-              <a:rPr lang="en-US" altLang="ko-KR" sz="1400" b="1">
-                <a:solidFill>
-                  <a:srgbClr val="F470B6"/>
-                </a:solidFill>
-                <a:latin typeface="Microsoft YaHei" panose="020B0503020204020204" pitchFamily="34" charset="-122"/>
-              </a:rPr>
-              <a:t>100</a:t>
-            </a:r>
-            <a:r>
-              <a:rPr lang="ko-KR" altLang="en-US" sz="1400" b="1">
-                <a:solidFill>
-                  <a:srgbClr val="F470B6"/>
-                </a:solidFill>
-                <a:latin typeface="Microsoft YaHei" panose="020B0503020204020204" pitchFamily="34" charset="-122"/>
-              </a:rPr>
-              <a:t>점부터 등장</a:t>
+              <a:t>🐍  몸이 한 칸 줄어요</a:t>
             </a:r>
             <a:endParaRPr lang="zh-CN" altLang="en-US" sz="1400" b="1">
               <a:solidFill>
@@ -7764,7 +7737,7 @@
         <p:spPr>
           <a:xfrm>
             <a:off x="4699000" y="4368800"/>
-            <a:ext cx="2743200" cy="507831"/>
+            <a:ext cx="2743200" cy="169277"/>
           </a:xfrm>
           <a:prstGeom prst="rect">
             <a:avLst/>
@@ -7778,58 +7751,13 @@
           <a:lstStyle/>
           <a:p>
             <a:r>
-              <a:rPr lang="en-US" altLang="ko-KR" sz="1100">
+              <a:rPr lang="ko-KR" altLang="en-US" sz="1100">
                 <a:solidFill>
                   <a:srgbClr val="94A3B8"/>
                 </a:solidFill>
                 <a:latin typeface="Microsoft YaHei" panose="020B0503020204020204" pitchFamily="34" charset="-122"/>
               </a:rPr>
-              <a:t>100</a:t>
-            </a:r>
-            <a:r>
-              <a:rPr lang="ko-KR" altLang="en-US" sz="1100">
-                <a:solidFill>
-                  <a:srgbClr val="94A3B8"/>
-                </a:solidFill>
-                <a:latin typeface="Microsoft YaHei" panose="020B0503020204020204" pitchFamily="34" charset="-122"/>
-              </a:rPr>
-              <a:t>점에 몬스터가 등장하고</a:t>
-            </a:r>
-            <a:r>
-              <a:rPr lang="en-US" altLang="ko-KR" sz="1100">
-                <a:solidFill>
-                  <a:srgbClr val="94A3B8"/>
-                </a:solidFill>
-                <a:latin typeface="Microsoft YaHei" panose="020B0503020204020204" pitchFamily="34" charset="-122"/>
-              </a:rPr>
-              <a:t>, 100</a:t>
-            </a:r>
-            <a:r>
-              <a:rPr lang="ko-KR" altLang="en-US" sz="1100">
-                <a:solidFill>
-                  <a:srgbClr val="94A3B8"/>
-                </a:solidFill>
-                <a:latin typeface="Microsoft YaHei" panose="020B0503020204020204" pitchFamily="34" charset="-122"/>
-              </a:rPr>
-              <a:t>점마다 한 마리씩 추가되어 최대 </a:t>
-            </a:r>
-            <a:r>
-              <a:rPr lang="en-US" altLang="ko-KR" sz="1100">
-                <a:solidFill>
-                  <a:srgbClr val="94A3B8"/>
-                </a:solidFill>
-                <a:latin typeface="Microsoft YaHei" panose="020B0503020204020204" pitchFamily="34" charset="-122"/>
-              </a:rPr>
-              <a:t>3</a:t>
-            </a:r>
-            <a:r>
-              <a:rPr lang="ko-KR" altLang="en-US" sz="1100">
-                <a:solidFill>
-                  <a:srgbClr val="94A3B8"/>
-                </a:solidFill>
-                <a:latin typeface="Microsoft YaHei" panose="020B0503020204020204" pitchFamily="34" charset="-122"/>
-              </a:rPr>
-              <a:t>마리까지 늘어납니다</a:t>
+              <a:t>몸에 부딪히면 한 칸 줄어요</a:t>
             </a:r>
             <a:r>
               <a:rPr lang="en-US" altLang="ko-KR" sz="1100">
@@ -7863,8 +7791,8 @@
         </p:nvSpPr>
         <p:spPr>
           <a:xfrm>
-            <a:off x="4699000" y="4927600"/>
-            <a:ext cx="2743200" cy="338554"/>
+            <a:off x="4699000" y="4749800"/>
+            <a:ext cx="2743200" cy="169277"/>
           </a:xfrm>
           <a:prstGeom prst="rect">
             <a:avLst/>
@@ -7884,7 +7812,7 @@
                 </a:solidFill>
                 <a:latin typeface="Microsoft YaHei" panose="020B0503020204020204" pitchFamily="34" charset="-122"/>
               </a:rPr>
-              <a:t>몸이나 몬스터에 부딪히면 몸이 짧아지지만 도전은 계속됩니다</a:t>
+              <a:t>몸이 남아 있으면 계속 플레이</a:t>
             </a:r>
             <a:r>
               <a:rPr lang="en-US" altLang="ko-KR" sz="1100">
@@ -7893,7 +7821,7 @@
                 </a:solidFill>
                 <a:latin typeface="Microsoft YaHei" panose="020B0503020204020204" pitchFamily="34" charset="-122"/>
               </a:rPr>
-              <a:t>.</a:t>
+              <a:t>!</a:t>
             </a:r>
             <a:endParaRPr lang="zh-CN" altLang="en-US" sz="1100">
               <a:solidFill>
@@ -7918,7 +7846,7 @@
         </p:nvSpPr>
         <p:spPr>
           <a:xfrm>
-            <a:off x="4699000" y="5283200"/>
+            <a:off x="4699000" y="5054600"/>
             <a:ext cx="2743200" cy="169277"/>
           </a:xfrm>
           <a:prstGeom prst="rect">
@@ -7939,7 +7867,7 @@
                 </a:solidFill>
                 <a:latin typeface="Microsoft YaHei" panose="020B0503020204020204" pitchFamily="34" charset="-122"/>
               </a:rPr>
-              <a:t>벽에 부딪히면 게임이 끝납니다</a:t>
+              <a:t>벽에 닿거나 몸이 너무 짧으면 게임 오버</a:t>
             </a:r>
             <a:r>
               <a:rPr lang="en-US" altLang="ko-KR" sz="1100">
@@ -8034,13 +7962,22 @@
           <a:lstStyle/>
           <a:p>
             <a:r>
+              <a:rPr lang="en-US" altLang="ko-KR" b="1">
+                <a:solidFill>
+                  <a:srgbClr val="E2E2F0"/>
+                </a:solidFill>
+                <a:latin typeface="Microsoft YaHei" panose="020B0503020204020204" pitchFamily="34" charset="-122"/>
+              </a:rPr>
+              <a:t>100</a:t>
+            </a:r>
+            <a:r>
               <a:rPr lang="ko-KR" altLang="en-US" b="1">
                 <a:solidFill>
                   <a:srgbClr val="E2E2F0"/>
                 </a:solidFill>
                 <a:latin typeface="Microsoft YaHei" panose="020B0503020204020204" pitchFamily="34" charset="-122"/>
               </a:rPr>
-              <a:t>언제든 바로 플레이</a:t>
+              <a:t>점부터 몬스터 등장</a:t>
             </a:r>
             <a:endParaRPr lang="zh-CN" altLang="en-US" b="1">
               <a:solidFill>
@@ -8086,7 +8023,7 @@
                 </a:solidFill>
                 <a:latin typeface="Microsoft YaHei" panose="020B0503020204020204" pitchFamily="34" charset="-122"/>
               </a:rPr>
-              <a:t>키보드</a:t>
+              <a:t>👾  첫 몬스터</a:t>
             </a:r>
             <a:r>
               <a:rPr lang="en-US" altLang="ko-KR" sz="1100" b="1">
@@ -8095,7 +8032,7 @@
                 </a:solidFill>
                 <a:latin typeface="Microsoft YaHei" panose="020B0503020204020204" pitchFamily="34" charset="-122"/>
               </a:rPr>
-              <a:t>: </a:t>
+              <a:t>: 100</a:t>
             </a:r>
             <a:r>
               <a:rPr lang="ko-KR" altLang="en-US" sz="1100" b="1">
@@ -8104,16 +8041,7 @@
                 </a:solidFill>
                 <a:latin typeface="Microsoft YaHei" panose="020B0503020204020204" pitchFamily="34" charset="-122"/>
               </a:rPr>
-              <a:t>방향키 </a:t>
-            </a:r>
-            <a:r>
-              <a:rPr lang="en-US" altLang="ko-KR" sz="1100" b="1">
-                <a:solidFill>
-                  <a:srgbClr val="22D3EE"/>
-                </a:solidFill>
-                <a:latin typeface="Microsoft YaHei" panose="020B0503020204020204" pitchFamily="34" charset="-122"/>
-              </a:rPr>
-              <a:t>/ WASD</a:t>
+              <a:t>점</a:t>
             </a:r>
             <a:endParaRPr lang="zh-CN" altLang="en-US" sz="1100" b="1">
               <a:solidFill>
@@ -8139,7 +8067,7 @@
         <p:spPr>
           <a:xfrm>
             <a:off x="8382000" y="4368800"/>
-            <a:ext cx="2743200" cy="169277"/>
+            <a:ext cx="2743200" cy="338554"/>
           </a:xfrm>
           <a:prstGeom prst="rect">
             <a:avLst/>
@@ -8159,7 +8087,7 @@
                 </a:solidFill>
                 <a:latin typeface="Microsoft YaHei" panose="020B0503020204020204" pitchFamily="34" charset="-122"/>
               </a:rPr>
-              <a:t>모바일</a:t>
+              <a:t>점수가 </a:t>
             </a:r>
             <a:r>
               <a:rPr lang="en-US" altLang="ko-KR" sz="1100">
@@ -8168,7 +8096,7 @@
                 </a:solidFill>
                 <a:latin typeface="Microsoft YaHei" panose="020B0503020204020204" pitchFamily="34" charset="-122"/>
               </a:rPr>
-              <a:t>: </a:t>
+              <a:t>100</a:t>
             </a:r>
             <a:r>
               <a:rPr lang="ko-KR" altLang="en-US" sz="1100">
@@ -8177,7 +8105,16 @@
                 </a:solidFill>
                 <a:latin typeface="Microsoft YaHei" panose="020B0503020204020204" pitchFamily="34" charset="-122"/>
               </a:rPr>
-              <a:t>스와이프 또는 화면 방향 패드</a:t>
+              <a:t>점 더 오를 때마다 한 마리씩 추가됩니다</a:t>
+            </a:r>
+            <a:r>
+              <a:rPr lang="en-US" altLang="ko-KR" sz="1100">
+                <a:solidFill>
+                  <a:srgbClr val="94A3B8"/>
+                </a:solidFill>
+                <a:latin typeface="Microsoft YaHei" panose="020B0503020204020204" pitchFamily="34" charset="-122"/>
+              </a:rPr>
+              <a:t>.</a:t>
             </a:r>
             <a:endParaRPr lang="zh-CN" altLang="en-US" sz="1100">
               <a:solidFill>
@@ -8223,7 +8160,7 @@
                 </a:solidFill>
                 <a:latin typeface="Microsoft YaHei" panose="020B0503020204020204" pitchFamily="34" charset="-122"/>
               </a:rPr>
-              <a:t>일시정지</a:t>
+              <a:t>최대 </a:t>
             </a:r>
             <a:r>
               <a:rPr lang="en-US" altLang="ko-KR" sz="1100">
@@ -8232,7 +8169,7 @@
                 </a:solidFill>
                 <a:latin typeface="Microsoft YaHei" panose="020B0503020204020204" pitchFamily="34" charset="-122"/>
               </a:rPr>
-              <a:t>, </a:t>
+              <a:t>3</a:t>
             </a:r>
             <a:r>
               <a:rPr lang="ko-KR" altLang="en-US" sz="1100">
@@ -8241,25 +8178,7 @@
                 </a:solidFill>
                 <a:latin typeface="Microsoft YaHei" panose="020B0503020204020204" pitchFamily="34" charset="-122"/>
               </a:rPr>
-              <a:t>효과음</a:t>
-            </a:r>
-            <a:r>
-              <a:rPr lang="en-US" altLang="ko-KR" sz="1100">
-                <a:solidFill>
-                  <a:srgbClr val="94A3B8"/>
-                </a:solidFill>
-                <a:latin typeface="Microsoft YaHei" panose="020B0503020204020204" pitchFamily="34" charset="-122"/>
-              </a:rPr>
-              <a:t>, </a:t>
-            </a:r>
-            <a:r>
-              <a:rPr lang="ko-KR" altLang="en-US" sz="1100">
-                <a:solidFill>
-                  <a:srgbClr val="94A3B8"/>
-                </a:solidFill>
-                <a:latin typeface="Microsoft YaHei" panose="020B0503020204020204" pitchFamily="34" charset="-122"/>
-              </a:rPr>
-              <a:t>진동을 지원하며 최고 점수는 기기에 저장됩니다</a:t>
+              <a:t>마리까지 늘어나니 움직임을 살피며 피하세요</a:t>
             </a:r>
             <a:r>
               <a:rPr lang="en-US" altLang="ko-KR" sz="1100">

</xml_diff>